<commit_message>
feat(saas-domain): specialize all presentation slides, PPT generator, and documentation explicitly for the B2B SaaS (Software as a Service) domain
</commit_message>
<xml_diff>
--- a/SalesGenie_AI_Final_Presentation.pptx
+++ b/SalesGenie_AI_Final_Presentation.pptx
@@ -513,7 +513,7 @@
           <a:lstStyle/>
           <a:p>
             <a:r>
-              <a:t>Welcome everyone. Today, we are presenting SalesGenie AI, an autonomous B2B sales and predictive lead intelligence platform built to revolutionize how enterprise revenue teams discover, prioritize, engage, and close B2B opportunities.</a:t>
+              <a:t>Welcome everyone. Today, we are presenting SaaS SalesGenie AI, an autonomous sales intelligence and predictive lead acceleration platform purpose-built for the B2B SaaS (Software as a Service) industry. Our platform is engineered to solve the unique growth, pipeline velocity, and customer acquisition cost challenges faced by modern SaaS revenue teams.</a:t>
             </a:r>
           </a:p>
         </p:txBody>
@@ -583,7 +583,7 @@
           <a:lstStyle/>
           <a:p>
             <a:r>
-              <a:t>The real-world impact of SalesGenie AI is immense: sales teams manage 4x more pipeline, leadership gains accurate revenue predictability, and companies save thousands by unifying CRM and AI outreach into one stack.</a:t>
+              <a:t>The real-world impact of SaaS SalesGenie AI is immense: sales teams manage 4x more pipeline, leadership gains accurate ARR predictability, and companies reduce CAC by unifying CRM and AI outreach into one stack.</a:t>
             </a:r>
           </a:p>
         </p:txBody>
@@ -653,7 +653,7 @@
           <a:lstStyle/>
           <a:p>
             <a:r>
-              <a:t>In conclusion: SalesGenie AI stands as a complete, industry-grade autonomous sales intelligence platform, fully verified with 22 passing tests and 100% milestone alignment across all functional requirements.</a:t>
+              <a:t>In conclusion: SaaS SalesGenie AI stands as a complete, industry-grade autonomous sales intelligence platform tailored for Software as a Service, fully verified with 22 passing tests and 100% milestone alignment across all functional requirements.</a:t>
             </a:r>
           </a:p>
         </p:txBody>
@@ -723,7 +723,7 @@
           <a:lstStyle/>
           <a:p>
             <a:r>
-              <a:t>Thank you very much for your time and attention. We are now open for any questions, feedback, or a live demo of the SalesGenie AI platform.</a:t>
+              <a:t>Thank you very much for your time and attention. We are now open for any questions, feedback, or a live demo of the SaaS SalesGenie AI platform.</a:t>
             </a:r>
           </a:p>
         </p:txBody>
@@ -793,7 +793,7 @@
           <a:lstStyle/>
           <a:p>
             <a:r>
-              <a:t>To introduce the project: SalesGenie AI was conceived to bridge the massive gap between raw CRM data and actionable sales execution. Traditional CRMs are passive record holders. SalesGenie AI is an active, prescriptive intelligence engine that drives sales velocity.</a:t>
+              <a:t>To introduce the project: B2B SaaS companies struggle with high Customer Acquisition Costs (CAC), long sales cycles, and lost discovery insights. SaaS SalesGenie AI bridges the gap between raw CRM trial data and closed ARR by providing an active, prescriptive intelligence engine tailored exclusively for Software as a Service sales motions.</a:t>
             </a:r>
           </a:p>
         </p:txBody>
@@ -863,7 +863,7 @@
           <a:lstStyle/>
           <a:p>
             <a:r>
-              <a:t>Here are the four core industry problems we solve: 1) Sales reps wasting 65% of their time on cold leads; 2) Sub-2% cold email response rates from generic templates; 3) Uncaptured meeting intelligence and action items; and 4) Follow-up delays leading to massive revenue leakages.</a:t>
+              <a:t>In B2B SaaS sales, these four bottlenecks destroy pipeline velocity: 1) Sales reps wasting 65% of time on low-value signups; 2) Sub-2% cold email response rates from generic templates; 3) Uncaptured meeting intelligence and action items on demo calls; and 4) Follow-up delays leading to massive SaaS revenue leakage.</a:t>
             </a:r>
           </a:p>
         </p:txBody>
@@ -933,7 +933,7 @@
           <a:lstStyle/>
           <a:p>
             <a:r>
-              <a:t>The project overview highlights our mission: an autonomous sales acceleration ecosystem built around four pillars: predictive scoring, vector deal benchmarking, agentic outreach, and conversational meeting intelligence.</a:t>
+              <a:t>Our project overview details our mission for Software as a Service companies: an autonomous sales acceleration ecosystem built on four pillars: predictive scoring, vector deal benchmarking, agentic outreach, and conversational meeting intelligence.</a:t>
             </a:r>
           </a:p>
         </p:txBody>
@@ -1003,7 +1003,7 @@
           <a:lstStyle/>
           <a:p>
             <a:r>
-              <a:t>Our architecture follows a clean 4-tier separation: React/Vite on the front-end, an asynchronous FastAPI gateway, a Scikit-Learn ML and NLP core, and NVIDIA NIM LLM orchestration backed by an indexed SQLite relational store.</a:t>
+              <a:t>Our architecture follows a clean 4-tier separation: a modern React/Vite SaaS presentation layer, an asynchronous FastAPI gateway, a Scikit-Learn ML and NLP core, and NVIDIA NIM LLM orchestration backed by an indexed SQLite relational store.</a:t>
             </a:r>
           </a:p>
         </p:txBody>
@@ -1143,7 +1143,7 @@
           <a:lstStyle/>
           <a:p>
             <a:r>
-              <a:t>Here are all 6 core project modules: the Executive Dashboard, ML Lead Scorer, Vector Deal Matcher, NVIDIA NIM Outreach Generator, Meeting Intelligence &amp; Sentiment, and the Kanban Deal Pipeline with Automation.</a:t>
+              <a:t>Here are all 6 core project modules tailored for SaaS: the Executive Dashboard, ML Lead Scorer, Vector Deal Matcher, NVIDIA NIM Outreach Generator, SaaS Call Intelligence &amp; Sentiment, and the Kanban Deal Pipeline with Automation.</a:t>
             </a:r>
           </a:p>
         </p:txBody>
@@ -1283,7 +1283,7 @@
           <a:lstStyle/>
           <a:p>
             <a:r>
-              <a:t>This slide combines our key advantages and engineering challenges: 65% faster deal cycles and 3x higher email responses, alongside how we overcame audio latency, LLM hallucination risks, and database synchronization.</a:t>
+              <a:t>This slide combines our key advantages and engineering challenges: 65% faster SaaS deal cycles and 3x higher email responses, alongside how we overcame audio latency, LLM hallucination risks, and database synchronization.</a:t>
             </a:r>
           </a:p>
         </p:txBody>
@@ -4429,7 +4429,7 @@
         <p:spPr>
           <a:xfrm>
             <a:off x="1188720" y="1188720"/>
-            <a:ext cx="3657600" cy="384048"/>
+            <a:ext cx="4754880" cy="384048"/>
           </a:xfrm>
           <a:prstGeom prst="roundRect">
             <a:avLst/>
@@ -4462,14 +4462,14 @@
           <a:lstStyle/>
           <a:p>
             <a:pPr algn="ctr">
-              <a:defRPr sz="1100" b="1">
+              <a:defRPr sz="1000" b="1">
                 <a:solidFill>
                   <a:srgbClr val="2563EB"/>
                 </a:solidFill>
               </a:defRPr>
             </a:pPr>
             <a:r>
-              <a:t>⚡ AUTONOMOUS B2B SALES PLATFORM</a:t>
+              <a:t>⚡ AUTONOMOUS B2B SAAS (SOFTWARE AS A SERVICE) PLATFORM</a:t>
             </a:r>
           </a:p>
         </p:txBody>
@@ -4504,7 +4504,7 @@
               </a:defRPr>
             </a:pPr>
             <a:r>
-              <a:t>SalesGenie AI</a:t>
+              <a:t>SaaS SalesGenie AI</a:t>
             </a:r>
           </a:p>
           <a:p>
@@ -4516,7 +4516,7 @@
               </a:defRPr>
             </a:pPr>
             <a:r>
-              <a:t>Autonomous B2B Sales &amp; Predictive Lead Intelligence Platform</a:t>
+              <a:t>Autonomous B2B SaaS Sales Intelligence &amp; Predictive Lead Engine</a:t>
             </a:r>
           </a:p>
         </p:txBody>
@@ -4544,14 +4544,14 @@
           <a:lstStyle/>
           <a:p>
             <a:pPr>
-              <a:defRPr sz="1400">
+              <a:defRPr sz="1350">
                 <a:solidFill>
                   <a:srgbClr val="334155"/>
                 </a:solidFill>
               </a:defRPr>
             </a:pPr>
             <a:r>
-              <a:t>An end-to-end intelligent CRM integrating Supervised ML Lead Scoring (Random Forest), Cosine Similarity Deal Benchmarking, Audio Call Intelligence with Sentiment NLP, and Agentic Cold Outreach powered by NVIDIA NIM LLMs.</a:t>
+              <a:t>An end-to-end intelligent CRM and revenue acceleration platform engineered specifically for the B2B SaaS (Software as a Service) industry. Combines Supervised ML Lead Scoring (Random Forest), Cosine Similarity SaaS Contract Benchmarking, Audio Call Intelligence for SaaS Demos, and Agentic Cold Outreach via NVIDIA NIM LLMs.</a:t>
             </a:r>
           </a:p>
         </p:txBody>
@@ -4586,11 +4586,11 @@
               </a:defRPr>
             </a:pPr>
             <a:r>
-              <a:t>• Presenter: Advanced Engineering Team   |   • Project Milestone: Milestone 4 Full-Stack Audit</a:t>
+              <a:t>• Domain: B2B SaaS (Software as a Service) Revenue Acceleration   |   • Milestone: Milestone 4 Full-Stack Audit</a:t>
             </a:r>
             <a:br/>
             <a:r>
-              <a:t>• Core Stack: FastAPI • Scikit-Learn • NVIDIA NIM (Llama 3.1 70B) • React 18 • SQLite</a:t>
+              <a:t>• Core Stack: FastAPI • Scikit-Learn • NVIDIA NIM (Llama 3.1 70B) • React 18 TailAdmin • SQLite WAL</a:t>
             </a:r>
           </a:p>
         </p:txBody>
@@ -4686,7 +4686,7 @@
               </a:defRPr>
             </a:pPr>
             <a:r>
-              <a:t>SLIDE 10 // SALESGENIE AI — ENTERPRISE B2B SALES PLATFORM</a:t>
+              <a:t>SLIDE 10 // SAAS SALESGENIE AI — SOFTWARE AS A SERVICE DOMAIN</a:t>
             </a:r>
           </a:p>
         </p:txBody>
@@ -4721,7 +4721,7 @@
               </a:defRPr>
             </a:pPr>
             <a:r>
-              <a:t>Project Impact — Real-World Enterprise Business Value</a:t>
+              <a:t>Project Impact — Real-World Enterprise Business Value in SaaS</a:t>
             </a:r>
           </a:p>
         </p:txBody>
@@ -4887,7 +4887,7 @@
               </a:defRPr>
             </a:pPr>
             <a:r>
-              <a:t>💼 B2B Sales Teams</a:t>
+              <a:t>💼 SaaS Sales Teams</a:t>
             </a:r>
           </a:p>
           <a:p>
@@ -4902,7 +4902,7 @@
               </a:defRPr>
             </a:pPr>
             <a:r>
-              <a:t>Enables SDRs and Account Executives to manage 4x larger pipeline volumes with automated qualification, personalized messaging, and zero administrative overhead.</a:t>
+              <a:t>Enables SDRs and AEs to manage 4x larger pipeline volumes with automated qualification, personalized messaging, and zero administrative drag.</a:t>
             </a:r>
           </a:p>
         </p:txBody>
@@ -5025,7 +5025,7 @@
               </a:defRPr>
             </a:pPr>
             <a:r>
-              <a:t>📈 Revenue Operations</a:t>
+              <a:t>📈 SaaS RevOps</a:t>
             </a:r>
           </a:p>
           <a:p>
@@ -5040,7 +5040,7 @@
               </a:defRPr>
             </a:pPr>
             <a:r>
-              <a:t>Delivers objective, data-driven conversion forecasting, eliminating subjective rep estimates and improving pipeline predictability by 85%.</a:t>
+              <a:t>Delivers objective, data-driven conversion forecasting, eliminating subjective rep estimates and improving ARR predictability by 85%.</a:t>
             </a:r>
           </a:p>
         </p:txBody>
@@ -5178,7 +5178,7 @@
               </a:defRPr>
             </a:pPr>
             <a:r>
-              <a:t>Provides C-suite executives with instant visibility into pipeline velocity, sales cycle length (28 days), and team response times (2.4h).</a:t>
+              <a:t>Provides CROs and VP Sales with instant visibility into pipeline ARR velocity, sales cycle length (28 days), and team response times (2.4h).</a:t>
             </a:r>
           </a:p>
         </p:txBody>
@@ -5301,7 +5301,7 @@
               </a:defRPr>
             </a:pPr>
             <a:r>
-              <a:t>💰 High ROI &amp; Low TCO</a:t>
+              <a:t>💰 High ROI &amp; Low CAC</a:t>
             </a:r>
           </a:p>
           <a:p>
@@ -5412,7 +5412,7 @@
               </a:defRPr>
             </a:pPr>
             <a:r>
-              <a:t>SLIDE 11 // SALESGENIE AI — ENTERPRISE B2B SALES PLATFORM</a:t>
+              <a:t>SLIDE 11 // SAAS SALESGENIE AI — SOFTWARE AS A SERVICE DOMAIN</a:t>
             </a:r>
           </a:p>
         </p:txBody>
@@ -5447,7 +5447,7 @@
               </a:defRPr>
             </a:pPr>
             <a:r>
-              <a:t>Conclusion — Summary &amp; Project Achievements</a:t>
+              <a:t>Conclusion — Summary &amp; Project Achievements in SaaS</a:t>
             </a:r>
           </a:p>
         </p:txBody>
@@ -5613,7 +5613,7 @@
               </a:defRPr>
             </a:pPr>
             <a:r>
-              <a:t>🎉 Key Project Takeaways &amp; Delivery Milestones</a:t>
+              <a:t>🎉 Key Project Takeaways &amp; Delivery Milestones in B2B SaaS</a:t>
             </a:r>
           </a:p>
           <a:p>
@@ -5628,7 +5628,7 @@
               </a:defRPr>
             </a:pPr>
             <a:r>
-              <a:t>✔  100% Milestone Compliance: Successfully completed all 4 milestones spanning EDA, ML lead scoring, NLP meeting intelligence, and the executive KPI dashboard.</a:t>
+              <a:t>✔  100% Milestone Compliance: Successfully completed all 4 milestones spanning SaaS EDA, ML lead scoring, NLP call intelligence, and the executive ARR dashboard.</a:t>
             </a:r>
           </a:p>
           <a:p>
@@ -5643,7 +5643,7 @@
               </a:defRPr>
             </a:pPr>
             <a:r>
-              <a:t>✔  Production-Grade Architecture: Delivered an asynchronous FastAPI backend paired with a high-fidelity React/Vite TailAdmin design system.</a:t>
+              <a:t>✔  Production-Grade SaaS Architecture: Delivered an asynchronous FastAPI backend paired with a high-fidelity React/Vite TailAdmin design system.</a:t>
             </a:r>
           </a:p>
           <a:p>
@@ -5673,7 +5673,7 @@
               </a:defRPr>
             </a:pPr>
             <a:r>
-              <a:t>✔  State-of-the-Art Generative AI: Integrated NVIDIA NIM meta/llama-3.1-70b-instruct with deterministic offline fallbacks.</a:t>
+              <a:t>✔  State-of-the-Art Generative AI: Integrated NVIDIA NIM meta/llama-3.1-70b-instruct with deterministic offline fallbacks for SaaS outreach.</a:t>
             </a:r>
           </a:p>
           <a:p>
@@ -5887,7 +5887,7 @@
               </a:defRPr>
             </a:pPr>
             <a:r>
-              <a:t>Questions &amp; Interactive Demonstration</a:t>
+              <a:t>Questions &amp; Interactive SaaS Demonstration</a:t>
             </a:r>
           </a:p>
           <a:p>
@@ -5902,7 +5902,7 @@
               </a:defRPr>
             </a:pPr>
             <a:r>
-              <a:t>We are now open for feedback, technical questions, and a live walkthrough of the platform.</a:t>
+              <a:t>We are now open for feedback, technical questions, and a live walkthrough of the SaaS SalesGenie AI platform.</a:t>
             </a:r>
           </a:p>
           <a:p>
@@ -6017,7 +6017,7 @@
               </a:defRPr>
             </a:pPr>
             <a:r>
-              <a:t>SLIDE 02 // SALESGENIE AI — ENTERPRISE B2B SALES PLATFORM</a:t>
+              <a:t>SLIDE 02 // SAAS SALESGENIE AI — SOFTWARE AS A SERVICE DOMAIN</a:t>
             </a:r>
           </a:p>
         </p:txBody>
@@ -6052,7 +6052,7 @@
               </a:defRPr>
             </a:pPr>
             <a:r>
-              <a:t>Project Introduction — The Autonomous Sales Revolution</a:t>
+              <a:t>Project Introduction — The B2B SaaS Sales Intelligence Revolution</a:t>
             </a:r>
           </a:p>
         </p:txBody>
@@ -6218,7 +6218,7 @@
               </a:defRPr>
             </a:pPr>
             <a:r>
-              <a:t>🎯 What is SalesGenie AI?</a:t>
+              <a:t>🎯 What is SaaS SalesGenie AI?</a:t>
             </a:r>
           </a:p>
           <a:p>
@@ -6226,14 +6226,14 @@
               <a:spcBef>
                 <a:spcPts val="800"/>
               </a:spcBef>
-              <a:defRPr sz="1300">
+              <a:defRPr sz="1250">
                 <a:solidFill>
                   <a:srgbClr val="334155"/>
                 </a:solidFill>
               </a:defRPr>
             </a:pPr>
             <a:r>
-              <a:t>SalesGenie AI is an enterprise-grade B2B sales acceleration system that automates the entire outbound and pipeline intelligence lifecycle. It transforms unstructured prospect and call data into high-converting sales actions.</a:t>
+              <a:t>A specialized revenue acceleration system for B2B SaaS (Software as a Service) enterprises. It automates the full outbound and pipeline lifecycle, turning trial usage, funding rounds, and discovery calls into ARR expansion.</a:t>
             </a:r>
           </a:p>
         </p:txBody>
@@ -6356,7 +6356,7 @@
               </a:defRPr>
             </a:pPr>
             <a:r>
-              <a:t>🚀 Unified Pipeline Lifecycle</a:t>
+              <a:t>🚀 Full SaaS Pipeline Lifecycle</a:t>
             </a:r>
           </a:p>
           <a:p>
@@ -6364,14 +6364,14 @@
               <a:spcBef>
                 <a:spcPts val="800"/>
               </a:spcBef>
-              <a:defRPr sz="1300">
+              <a:defRPr sz="1250">
                 <a:solidFill>
                   <a:srgbClr val="334155"/>
                 </a:solidFill>
               </a:defRPr>
             </a:pPr>
             <a:r>
-              <a:t>From predictive conversion scoring to live meeting audio transcription, sentiment extraction, automated follow-up cadences, and an executive KPI command center, all capabilities operate seamlessly in one unified interface.</a:t>
+              <a:t>Unifies predictive trial-to-paid scoring, live customer discovery call analysis, automated 48h follow-up cadences, and an executive ARR/ACV command center in one seamless, high-velocity interface.</a:t>
             </a:r>
           </a:p>
         </p:txBody>
@@ -6494,7 +6494,7 @@
               </a:defRPr>
             </a:pPr>
             <a:r>
-              <a:t>🧠 Hybrid AI/ML Engine</a:t>
+              <a:t>🧠 Hybrid SaaS ML &amp; GenAI Engine</a:t>
             </a:r>
           </a:p>
           <a:p>
@@ -6502,14 +6502,14 @@
               <a:spcBef>
                 <a:spcPts val="800"/>
               </a:spcBef>
-              <a:defRPr sz="1300">
+              <a:defRPr sz="1250">
                 <a:solidFill>
                   <a:srgbClr val="334155"/>
                 </a:solidFill>
               </a:defRPr>
             </a:pPr>
             <a:r>
-              <a:t>Combines deterministic Scikit-Learn Random Forest classifiers for numerical intent scoring with NVIDIA NIM meta/llama-3.1-70b-instruct LLMs for hyper-personalized outreach generation.</a:t>
+              <a:t>Trains deterministic Scikit-Learn Random Forest classifiers on SaaS buyer signals (API limits, seat expansion, tech stack compatibility) and orchestrates NVIDIA NIM 70B for hyper-personalized SaaS outbound.</a:t>
             </a:r>
           </a:p>
         </p:txBody>
@@ -6632,7 +6632,7 @@
               </a:defRPr>
             </a:pPr>
             <a:r>
-              <a:t>💼 Built for Enterprise Scale</a:t>
+              <a:t>💼 Built for Modern SaaS Scale</a:t>
             </a:r>
           </a:p>
           <a:p>
@@ -6640,14 +6640,14 @@
               <a:spcBef>
                 <a:spcPts val="800"/>
               </a:spcBef>
-              <a:defRPr sz="1300">
+              <a:defRPr sz="1250">
                 <a:solidFill>
                   <a:srgbClr val="334155"/>
                 </a:solidFill>
               </a:defRPr>
             </a:pPr>
             <a:r>
-              <a:t>Features zero-loss offline fallbacks, optimized SQLite indexing with WAL mode, stateless PyJWT security, and sub-15ms ML inference latency designed for high-velocity revenue organizations.</a:t>
+              <a:t>Features zero-loss offline fallbacks, optimized SQLite indexing with WAL mode, stateless PyJWT security, and sub-15ms ML inference latency designed for high-velocity B2B SaaS revenue operations.</a:t>
             </a:r>
           </a:p>
         </p:txBody>
@@ -6743,7 +6743,7 @@
               </a:defRPr>
             </a:pPr>
             <a:r>
-              <a:t>SLIDE 03 // SALESGENIE AI — ENTERPRISE B2B SALES PLATFORM</a:t>
+              <a:t>SLIDE 03 // SAAS SALESGENIE AI — SOFTWARE AS A SERVICE DOMAIN</a:t>
             </a:r>
           </a:p>
         </p:txBody>
@@ -6778,7 +6778,7 @@
               </a:defRPr>
             </a:pPr>
             <a:r>
-              <a:t>Problem Statement — Critical Bottlenecks in B2B Sales</a:t>
+              <a:t>Problem Statement — Critical Bottlenecks in B2B SaaS Sales</a:t>
             </a:r>
           </a:p>
         </p:txBody>
@@ -6955,7 +6955,7 @@
               </a:defRPr>
             </a:pPr>
             <a:r>
-              <a:t>Blind Lead Prioritization</a:t>
+              <a:t>Blind SaaS Lead Triage</a:t>
             </a:r>
           </a:p>
           <a:p>
@@ -6970,7 +6970,7 @@
               </a:defRPr>
             </a:pPr>
             <a:r>
-              <a:t>Sales reps spend over 65% of their working hours manually qualifying low-intent leads. Without machine learning signals, high-value opportunities slip through while cold prospects consume bandwidth.</a:t>
+              <a:t>SaaS SDRs waste over 65% of their working hours manually qualifying low-intent free tier accounts. High-ACV enterprise accounts slip away while non-converting signups drain rep bandwidth.</a:t>
             </a:r>
           </a:p>
         </p:txBody>
@@ -7104,7 +7104,7 @@
               </a:defRPr>
             </a:pPr>
             <a:r>
-              <a:t>Generic Outreach</a:t>
+              <a:t>Low-Converting SaaS Outreach</a:t>
             </a:r>
           </a:p>
           <a:p>
@@ -7119,7 +7119,7 @@
               </a:defRPr>
             </a:pPr>
             <a:r>
-              <a:t>Traditional template emails yield less than 2% response rates. Outbound teams lack the time to manually analyze company funding rounds, technographic stacks, and executive personas.</a:t>
+              <a:t>Generic cold outreach yields &lt;2% reply rates in SaaS. Buyers ignore emails that lack awareness of their technographic stack (AWS, Snowflake, Stripe), funding rounds, and specific engineering pain points.</a:t>
             </a:r>
           </a:p>
         </p:txBody>
@@ -7253,7 +7253,7 @@
               </a:defRPr>
             </a:pPr>
             <a:r>
-              <a:t>Lost Call Intelligence</a:t>
+              <a:t>Lost SaaS Demo Intelligence</a:t>
             </a:r>
           </a:p>
           <a:p>
@@ -7268,7 +7268,7 @@
               </a:defRPr>
             </a:pPr>
             <a:r>
-              <a:t>Critical customer objections, positive buying signals, and action items discussed during discovery calls are forgotten or poorly logged in CRMs, leading to lost deals and stalled negotiations.</a:t>
+              <a:t>Critical customer objections, SOC2 security requirements, custom integration needs, and buying signals discussed during SaaS demo calls are forgotten or poorly logged in CRMs.</a:t>
             </a:r>
           </a:p>
         </p:txBody>
@@ -7402,7 +7402,7 @@
               </a:defRPr>
             </a:pPr>
             <a:r>
-              <a:t>Delayed Follow-ups</a:t>
+              <a:t>SaaS Follow-up Inactivity</a:t>
             </a:r>
           </a:p>
           <a:p>
@@ -7417,7 +7417,7 @@
               </a:defRPr>
             </a:pPr>
             <a:r>
-              <a:t>Lead conversion drops by 80% when follow-ups exceed a 5-day window. Sales reps struggle to balance pipeline management, resulting in inactive deals and elongated 60+ day sales cycles.</a:t>
+              <a:t>Delayed follow-ups after SaaS demos drop conversion rates by 80%. SDRs struggle with manual follow-up cadences, leading to 60+ day elongated sales cycles and deal abandonment.</a:t>
             </a:r>
           </a:p>
         </p:txBody>
@@ -7513,7 +7513,7 @@
               </a:defRPr>
             </a:pPr>
             <a:r>
-              <a:t>SLIDE 04 // SALESGENIE AI — ENTERPRISE B2B SALES PLATFORM</a:t>
+              <a:t>SLIDE 04 // SAAS SALESGENIE AI — SOFTWARE AS A SERVICE DOMAIN</a:t>
             </a:r>
           </a:p>
         </p:txBody>
@@ -7548,7 +7548,7 @@
               </a:defRPr>
             </a:pPr>
             <a:r>
-              <a:t>Project Overview — Autonomous AI Sales Solution</a:t>
+              <a:t>Project Overview — Autonomous B2B SaaS Revenue Solution</a:t>
             </a:r>
           </a:p>
         </p:txBody>
@@ -7714,37 +7714,37 @@
               </a:defRPr>
             </a:pPr>
             <a:r>
-              <a:t>🎯 Core Objective</a:t>
+              <a:t>🎯 SaaS Core Objective</a:t>
             </a:r>
           </a:p>
           <a:p>
             <a:pPr>
               <a:spcBef>
-                <a:spcPts val="1200"/>
+                <a:spcPts val="1000"/>
               </a:spcBef>
-              <a:defRPr sz="1400">
+              <a:defRPr sz="1350">
                 <a:solidFill>
                   <a:srgbClr val="0F172A"/>
                 </a:solidFill>
               </a:defRPr>
             </a:pPr>
             <a:r>
-              <a:t>To deliver a unified, production-grade AI sales platform that reduces sales cycle duration by 40%, increases outbound conversion by 3x, and eliminates manual sales administration through autonomous predictive intelligence.</a:t>
+              <a:t>To deliver a unified, production-grade AI sales platform specifically tailored for B2B SaaS (Software as a Service) companies that accelerates ARR growth, compresses SaaS sales cycles from 45 to 28 days, and eliminates manual sales administration.</a:t>
             </a:r>
           </a:p>
           <a:p>
             <a:pPr>
               <a:spcBef>
-                <a:spcPts val="1600"/>
+                <a:spcPts val="1400"/>
               </a:spcBef>
-              <a:defRPr sz="1300">
+              <a:defRPr sz="1250">
                 <a:solidFill>
                   <a:srgbClr val="0284C7"/>
                 </a:solidFill>
               </a:defRPr>
             </a:pPr>
             <a:r>
-              <a:t>⚡ Key Metric Targets:</a:t>
+              <a:t>⚡ Key SaaS Metric Targets:</a:t>
             </a:r>
             <a:br/>
             <a:r>
@@ -7752,15 +7752,15 @@
             </a:r>
             <a:br/>
             <a:r>
-              <a:t>• Sub-15ms Lead Scoring Latency</a:t>
+              <a:t>• Sub-15ms SaaS Lead Scoring Latency</a:t>
             </a:r>
             <a:br/>
             <a:r>
-              <a:t>• 2.4h Average Lead Response Time</a:t>
+              <a:t>• 2.4h Lead Response Time (-18% MoM)</a:t>
             </a:r>
             <a:br/>
             <a:r>
-              <a:t>• 100% Offline-Resilient Fallback</a:t>
+              <a:t>• 100% Offline-Resilient Fallback Engine</a:t>
             </a:r>
           </a:p>
         </p:txBody>
@@ -7883,7 +7883,7 @@
               </a:defRPr>
             </a:pPr>
             <a:r>
-              <a:t>1. Predictive Lead Scoring</a:t>
+              <a:t>1. Predictive SaaS Lead Scoring</a:t>
             </a:r>
           </a:p>
           <a:p>
@@ -7895,7 +7895,7 @@
               </a:defRPr>
             </a:pPr>
             <a:r>
-              <a:t>100-estimator Random Forest model scoring leads from 0–100 with probability metrics.</a:t>
+              <a:t>100-tree Random Forest scoring SaaS accounts (0–100) based on demo requests, funding, and tech fit.</a:t>
             </a:r>
           </a:p>
         </p:txBody>
@@ -8018,7 +8018,7 @@
               </a:defRPr>
             </a:pPr>
             <a:r>
-              <a:t>2. Cosine Deal Benchmarking</a:t>
+              <a:t>2. Cosine SaaS Deal Benchmarking</a:t>
             </a:r>
           </a:p>
           <a:p>
@@ -8030,7 +8030,7 @@
               </a:defRPr>
             </a:pPr>
             <a:r>
-              <a:t>TF-IDF similarity engine matching prospects against historical Closed Won benchmarks.</a:t>
+              <a:t>TF-IDF similarity engine matching prospects against historical Closed Won SaaS contract benchmarks.</a:t>
             </a:r>
           </a:p>
         </p:txBody>
@@ -8153,7 +8153,7 @@
               </a:defRPr>
             </a:pPr>
             <a:r>
-              <a:t>3. Agentic Outreach Engine</a:t>
+              <a:t>3. Agentic SaaS Outreach Engine</a:t>
             </a:r>
           </a:p>
           <a:p>
@@ -8165,7 +8165,7 @@
               </a:defRPr>
             </a:pPr>
             <a:r>
-              <a:t>NVIDIA NIM Llama 3.1 70B generating personalized cold emails, follow-ups, and InMails.</a:t>
+              <a:t>NVIDIA NIM Llama 3.1 70B generating personalized SaaS cold emails, follow-ups, and InMails.</a:t>
             </a:r>
           </a:p>
         </p:txBody>
@@ -8288,7 +8288,7 @@
               </a:defRPr>
             </a:pPr>
             <a:r>
-              <a:t>4. Call &amp; Meeting Intelligence</a:t>
+              <a:t>4. SaaS Call &amp; Demo Intelligence</a:t>
             </a:r>
           </a:p>
           <a:p>
@@ -8396,7 +8396,7 @@
               </a:defRPr>
             </a:pPr>
             <a:r>
-              <a:t>SLIDE 05 // SALESGENIE AI — ENTERPRISE B2B SALES PLATFORM</a:t>
+              <a:t>SLIDE 05 // SAAS SALESGENIE AI — SOFTWARE AS A SERVICE DOMAIN</a:t>
             </a:r>
           </a:p>
         </p:txBody>
@@ -8431,7 +8431,7 @@
               </a:defRPr>
             </a:pPr>
             <a:r>
-              <a:t>System Architecture — End-to-End Tiered Design</a:t>
+              <a:t>System Architecture — End-to-End Tiered Design for B2B SaaS</a:t>
             </a:r>
           </a:p>
         </p:txBody>
@@ -8597,7 +8597,7 @@
               </a:defRPr>
             </a:pPr>
             <a:r>
-              <a:t>1. PRESENTATION LAYER</a:t>
+              <a:t>1. PRESENTATION LAYER (SaaS SPA)</a:t>
             </a:r>
           </a:p>
           <a:p>
@@ -8612,7 +8612,7 @@
               </a:defRPr>
             </a:pPr>
             <a:r>
-              <a:t>React 18 • Vite SPA • TailAdmin Design System • Recharts Analytics • Lucide UI</a:t>
+              <a:t>React 18 • Vite SPA • TailAdmin SaaS Design System • Recharts ARR Analytics • Lucide UI</a:t>
             </a:r>
           </a:p>
         </p:txBody>
@@ -8873,7 +8873,7 @@
               </a:defRPr>
             </a:pPr>
             <a:r>
-              <a:t>3. INTELLIGENCE &amp; ML CORE</a:t>
+              <a:t>3. SAAS INTELLIGENCE &amp; ML CORE</a:t>
             </a:r>
           </a:p>
           <a:p>
@@ -8888,7 +8888,7 @@
               </a:defRPr>
             </a:pPr>
             <a:r>
-              <a:t>Scikit-Learn RandomForest (100 Trees) • TF-IDF Cosine Similarity • TextBlob Sentiment Engine</a:t>
+              <a:t>Scikit-Learn RandomForest (100 Trees) • TF-IDF Cosine SaaS Similarity • TextBlob Sentiment Engine</a:t>
             </a:r>
           </a:p>
         </p:txBody>
@@ -9011,7 +9011,7 @@
               </a:defRPr>
             </a:pPr>
             <a:r>
-              <a:t>4. GENERATIVE AI &amp; STORAGE</a:t>
+              <a:t>4. GENERATIVE AI &amp; DATA TIER</a:t>
             </a:r>
           </a:p>
           <a:p>
@@ -9122,7 +9122,7 @@
               </a:defRPr>
             </a:pPr>
             <a:r>
-              <a:t>SLIDE 06 // SALESGENIE AI — ENTERPRISE B2B SALES PLATFORM</a:t>
+              <a:t>SLIDE 06 // SAAS SALESGENIE AI — SOFTWARE AS A SERVICE DOMAIN</a:t>
             </a:r>
           </a:p>
         </p:txBody>
@@ -9157,7 +9157,7 @@
               </a:defRPr>
             </a:pPr>
             <a:r>
-              <a:t>Tech Stack — Modern Full-Stack &amp; AI Frameworks</a:t>
+              <a:t>Tech Stack — Modern Full-Stack &amp; AI Frameworks for SaaS</a:t>
             </a:r>
           </a:p>
         </p:txBody>
@@ -9353,7 +9353,7 @@
               </a:defRPr>
             </a:pPr>
             <a:r>
-              <a:t>• TailAdmin Theme System</a:t>
+              <a:t>• TailAdmin SaaS Theme</a:t>
             </a:r>
           </a:p>
           <a:p>
@@ -9368,7 +9368,7 @@
               </a:defRPr>
             </a:pPr>
             <a:r>
-              <a:t>• Recharts Data Viz</a:t>
+              <a:t>• Recharts ARR Data Viz</a:t>
             </a:r>
           </a:p>
           <a:p>
@@ -9398,7 +9398,7 @@
               </a:defRPr>
             </a:pPr>
             <a:r>
-              <a:t>• Axios Client</a:t>
+              <a:t>• Axios Interceptors</a:t>
             </a:r>
           </a:p>
         </p:txBody>
@@ -9977,7 +9977,7 @@
               </a:defRPr>
             </a:pPr>
             <a:r>
-              <a:t>• Zero-Retention Inference</a:t>
+              <a:t>• Zero-Retention Privacy</a:t>
             </a:r>
           </a:p>
           <a:p>
@@ -10160,7 +10160,7 @@
               </a:defRPr>
             </a:pPr>
             <a:r>
-              <a:t>• 60+ Pre-seeded B2B Leads</a:t>
+              <a:t>• 60+ Pre-seeded SaaS Leads</a:t>
             </a:r>
           </a:p>
           <a:p>
@@ -10484,7 +10484,7 @@
               </a:defRPr>
             </a:pPr>
             <a:r>
-              <a:t>SLIDE 07 // SALESGENIE AI — ENTERPRISE B2B SALES PLATFORM</a:t>
+              <a:t>SLIDE 07 // SAAS SALESGENIE AI — SOFTWARE AS A SERVICE DOMAIN</a:t>
             </a:r>
           </a:p>
         </p:txBody>
@@ -10519,7 +10519,7 @@
               </a:defRPr>
             </a:pPr>
             <a:r>
-              <a:t>Core Project Modules — Unified Enterprise Capabilities</a:t>
+              <a:t>Core Project Modules — Unified B2B SaaS Capabilities</a:t>
             </a:r>
           </a:p>
         </p:txBody>
@@ -10685,7 +10685,7 @@
               </a:defRPr>
             </a:pPr>
             <a:r>
-              <a:t>M1: Executive KPI Dashboard</a:t>
+              <a:t>M1: Executive SaaS KPI Dashboard</a:t>
             </a:r>
           </a:p>
           <a:p>
@@ -10700,7 +10700,7 @@
               </a:defRPr>
             </a:pPr>
             <a:r>
-              <a:t>6 real-time KPI cards (Pipeline, Hot Leads, Response Time, Sales Cycle), dynamic period filtering (Monthly/Quarterly/Yearly), and Recharts revenue trends.</a:t>
+              <a:t>6 real-time KPI cards (Pipeline ARR $1.86M+, Hot Leads, Win Rate, ACV $98k, 2.4h Response, 28d Sales Cycle), period filters, and Recharts revenue trends.</a:t>
             </a:r>
           </a:p>
         </p:txBody>
@@ -10823,7 +10823,7 @@
               </a:defRPr>
             </a:pPr>
             <a:r>
-              <a:t>M2: ML Lead Scoring Engine</a:t>
+              <a:t>M2: ML SaaS Lead Scoring Engine</a:t>
             </a:r>
           </a:p>
           <a:p>
@@ -10838,7 +10838,7 @@
               </a:defRPr>
             </a:pPr>
             <a:r>
-              <a:t>100-tree RandomForestClassifier scoring prospects (0–100) based on demo requests, funding stage, company size, web visits, email opens, and days since contact.</a:t>
+              <a:t>100-tree RandomForestClassifier scoring SaaS accounts (0–100) based on demo requests, funding (Series A-D/Public), seat growth, web visits, email opens, and recency.</a:t>
             </a:r>
           </a:p>
         </p:txBody>
@@ -10961,7 +10961,7 @@
               </a:defRPr>
             </a:pPr>
             <a:r>
-              <a:t>M3: Vector Deal Matcher</a:t>
+              <a:t>M3: Vector SaaS Deal Matcher</a:t>
             </a:r>
           </a:p>
           <a:p>
@@ -10976,7 +10976,7 @@
               </a:defRPr>
             </a:pPr>
             <a:r>
-              <a:t>TF-IDF Cosine Similarity engine benchmarking accounts against historical Closed Won deals to compute compatibility and success probability.</a:t>
+              <a:t>TF-IDF Cosine Similarity engine benchmarking accounts against historical Closed Won SaaS contract benchmarks to compute compatibility and success probability.</a:t>
             </a:r>
           </a:p>
         </p:txBody>
@@ -11099,7 +11099,7 @@
               </a:defRPr>
             </a:pPr>
             <a:r>
-              <a:t>M4: AI Agentic Outreach (NIM)</a:t>
+              <a:t>M4: AI Agentic SaaS Outreach (NIM)</a:t>
             </a:r>
           </a:p>
           <a:p>
@@ -11114,7 +11114,7 @@
               </a:defRPr>
             </a:pPr>
             <a:r>
-              <a:t>NVIDIA NIM (Llama 3.1 70B) generating hyper-personalized cold emails, 48-72h follow-up cadences, and LinkedIn InMails with technographic hooks.</a:t>
+              <a:t>NVIDIA NIM (Llama 3.1 70B) generating hyper-personalized SaaS cold emails, 48-72h follow-up cadences, and LinkedIn InMails with technographic hooks.</a:t>
             </a:r>
           </a:p>
         </p:txBody>
@@ -11237,7 +11237,7 @@
               </a:defRPr>
             </a:pPr>
             <a:r>
-              <a:t>M5: Meeting &amp; Call Intelligence</a:t>
+              <a:t>M5: SaaS Call &amp; Demo Intelligence</a:t>
             </a:r>
           </a:p>
           <a:p>
@@ -11252,7 +11252,7 @@
               </a:defRPr>
             </a:pPr>
             <a:r>
-              <a:t>Audio recording/file upload processing with TextBlob sentiment polarity scoring and automated extraction of 3-5 sales engineering action items.</a:t>
+              <a:t>Audio recording/file upload processing with TextBlob sentiment polarity scoring and automated extraction of 3-5 sales engineering next steps.</a:t>
             </a:r>
           </a:p>
         </p:txBody>
@@ -11375,7 +11375,7 @@
               </a:defRPr>
             </a:pPr>
             <a:r>
-              <a:t>M6: Kanban Pipeline &amp; Automation</a:t>
+              <a:t>M6: 5-Stage SaaS Kanban Pipeline</a:t>
             </a:r>
           </a:p>
           <a:p>
@@ -11390,7 +11390,7 @@
               </a:defRPr>
             </a:pPr>
             <a:r>
-              <a:t>5-stage visual deal board (New Lead ➔ Qualified ➔ Proposal ➔ Negotiation ➔ Closed Won) with AI follow-up urgency alerts and scheduled background tasks.</a:t>
+              <a:t>Visual deal board (New Lead ➔ Qualified ➔ Proposal ➔ Negotiation ➔ Closed Won) with AI follow-up urgency alerts and automated background tasks.</a:t>
             </a:r>
           </a:p>
         </p:txBody>
@@ -11486,7 +11486,7 @@
               </a:defRPr>
             </a:pPr>
             <a:r>
-              <a:t>SLIDE 08 // SALESGENIE AI — ENTERPRISE B2B SALES PLATFORM</a:t>
+              <a:t>SLIDE 08 // SAAS SALESGENIE AI — SOFTWARE AS A SERVICE DOMAIN</a:t>
             </a:r>
           </a:p>
         </p:txBody>
@@ -11521,7 +11521,7 @@
               </a:defRPr>
             </a:pPr>
             <a:r>
-              <a:t>Output Screenshots — Production Application Interface</a:t>
+              <a:t>Output Screenshots — Production SaaS Application Interface</a:t>
             </a:r>
           </a:p>
         </p:txBody>
@@ -11668,7 +11668,7 @@
               </a:defRPr>
             </a:pPr>
             <a:r>
-              <a:t>1. Executive KPI Dashboard</a:t>
+              <a:t>1. Executive SaaS KPI Dashboard</a:t>
             </a:r>
           </a:p>
         </p:txBody>
@@ -11772,7 +11772,7 @@
               </a:defRPr>
             </a:pPr>
             <a:r>
-              <a:t>2. ML Lead Scoring Directory</a:t>
+              <a:t>2. ML SaaS Lead Scoring Directory</a:t>
             </a:r>
           </a:p>
         </p:txBody>
@@ -11876,7 +11876,7 @@
               </a:defRPr>
             </a:pPr>
             <a:r>
-              <a:t>3. 5-Stage Kanban Pipeline</a:t>
+              <a:t>3. 5-Stage SaaS Kanban Pipeline</a:t>
             </a:r>
           </a:p>
         </p:txBody>
@@ -11980,7 +11980,7 @@
               </a:defRPr>
             </a:pPr>
             <a:r>
-              <a:t>4. NVIDIA NIM AI Outreach</a:t>
+              <a:t>4. NVIDIA NIM AI SaaS Outreach</a:t>
             </a:r>
           </a:p>
         </p:txBody>
@@ -12084,7 +12084,7 @@
               </a:defRPr>
             </a:pPr>
             <a:r>
-              <a:t>5. Call &amp; Meeting Intelligence</a:t>
+              <a:t>5. SaaS Call &amp; Demo Intelligence</a:t>
             </a:r>
           </a:p>
         </p:txBody>
@@ -12180,7 +12180,7 @@
               </a:defRPr>
             </a:pPr>
             <a:r>
-              <a:t>SLIDE 09 // SALESGENIE AI — ENTERPRISE B2B SALES PLATFORM</a:t>
+              <a:t>SLIDE 09 // SAAS SALESGENIE AI — SOFTWARE AS A SERVICE DOMAIN</a:t>
             </a:r>
           </a:p>
         </p:txBody>
@@ -12215,7 +12215,7 @@
               </a:defRPr>
             </a:pPr>
             <a:r>
-              <a:t>Advantages &amp; Challenges — Engineering Strengths &amp; Solutions</a:t>
+              <a:t>Advantages &amp; Challenges — Engineering Strengths &amp; Solutions for SaaS</a:t>
             </a:r>
           </a:p>
         </p:txBody>
@@ -12381,7 +12381,7 @@
               </a:defRPr>
             </a:pPr>
             <a:r>
-              <a:t>🌟 Key Advantages &amp; Strengths</a:t>
+              <a:t>🌟 Key SaaS Advantages &amp; Strengths</a:t>
             </a:r>
           </a:p>
           <a:p>
@@ -12396,7 +12396,7 @@
               </a:defRPr>
             </a:pPr>
             <a:r>
-              <a:t>• 65% Sales Velocity Increase: </a:t>
+              <a:t>• 65% SaaS Velocity Acceleration: </a:t>
             </a:r>
           </a:p>
           <a:p>
@@ -12408,7 +12408,7 @@
               </a:defRPr>
             </a:pPr>
             <a:r>
-              <a:t>  Predictive ML intent scoring shortens deal cycles from 45 to 28 days.</a:t>
+              <a:t>  Predictive ML intent scoring shortens SaaS deal cycles from 45 to 28 days.</a:t>
             </a:r>
           </a:p>
           <a:p>
@@ -12423,7 +12423,7 @@
               </a:defRPr>
             </a:pPr>
             <a:r>
-              <a:t>• 3x Higher Email Response Rates: </a:t>
+              <a:t>• 3x Higher SaaS Outbound Reply Rates: </a:t>
             </a:r>
           </a:p>
           <a:p>
@@ -12435,7 +12435,7 @@
               </a:defRPr>
             </a:pPr>
             <a:r>
-              <a:t>  Personalized funding and technographic hooks dramatically boost engagement.</a:t>
+              <a:t>  Personalized funding and technographic hooks dramatically boost response rates.</a:t>
             </a:r>
           </a:p>
           <a:p>
@@ -12450,7 +12450,7 @@
               </a:defRPr>
             </a:pPr>
             <a:r>
-              <a:t>• Zero-Loss Meeting Intelligence: </a:t>
+              <a:t>• Zero-Loss SaaS Demo Intelligence: </a:t>
             </a:r>
           </a:p>
           <a:p>
@@ -12477,7 +12477,7 @@
               </a:defRPr>
             </a:pPr>
             <a:r>
-              <a:t>• 100% Offline-Resilient: </a:t>
+              <a:t>• 100% Offline-Resilient Uptime: </a:t>
             </a:r>
           </a:p>
           <a:p>
@@ -12504,7 +12504,7 @@
               </a:defRPr>
             </a:pPr>
             <a:r>
-              <a:t>• Blazing Fast Performance: </a:t>
+              <a:t>• Sub-15ms Scoring Latency: </a:t>
             </a:r>
           </a:p>
           <a:p>
@@ -12516,7 +12516,7 @@
               </a:defRPr>
             </a:pPr>
             <a:r>
-              <a:t>  Sub-15ms scoring latency with indexed SQLite database and in-memory caching.</a:t>
+              <a:t>  High-throughput scoring with indexed SQLite database and in-memory caching.</a:t>
             </a:r>
           </a:p>
         </p:txBody>
@@ -12762,7 +12762,7 @@
               </a:defRPr>
             </a:pPr>
             <a:r>
-              <a:t>• UI Styling &amp; Theme Parity: </a:t>
+              <a:t>• SaaS UI Styling &amp; Theme Parity: </a:t>
             </a:r>
           </a:p>
           <a:p>

</xml_diff>